<commit_message>
slides/about: replace leftover Quantum Computing boilerplate with AI-security text
Co-Authored-By: Claude Opus 4.8 <noreply@anthropic.com>
</commit_message>
<xml_diff>
--- a/slides/release/00__about.pptx
+++ b/slides/release/00__about.pptx
@@ -2437,7 +2437,7 @@
           <a:p>
             <a:pPr lvl="1"/>
             <a:r>
-              <a:t> Familiarity with QC (scale of 1 - 4 ;  1 - new,   4 - expert)</a:t>
+              <a:t> Familiarity with AI security (scale of 1 - 4 ;  1 - new,   4 - expert)</a:t>
             </a:r>
           </a:p>
           <a:p>
@@ -3054,13 +3054,13 @@
           </a:p>
           <a:p>
             <a:r>
-              <a:t> This is a Quantum Computing class</a:t>
+              <a:t> This is an AI security class</a:t>
             </a:r>
           </a:p>
           <a:p>
             <a:pPr lvl="1"/>
             <a:r>
-              <a:t> No previous knowledge is assumed (but may be helpful)</a:t>
+              <a:t> Intermediate to advanced; comfort with HTTP/API security and the OWASP Top 10 helps</a:t>
             </a:r>
           </a:p>
           <a:p>

</xml_diff>